<commit_message>
MCP Tools creation : temporay stage. using LLM
</commit_message>
<xml_diff>
--- a/Specs/Mockup.pptx
+++ b/Specs/Mockup.pptx
@@ -6,12 +6,13 @@
   </p:sldMasterIdLst>
   <p:sldIdLst>
     <p:sldId id="256" r:id="rId2"/>
-    <p:sldId id="257" r:id="rId3"/>
-    <p:sldId id="258" r:id="rId4"/>
-    <p:sldId id="259" r:id="rId5"/>
-    <p:sldId id="260" r:id="rId6"/>
-    <p:sldId id="261" r:id="rId7"/>
-    <p:sldId id="262" r:id="rId8"/>
+    <p:sldId id="263" r:id="rId3"/>
+    <p:sldId id="257" r:id="rId4"/>
+    <p:sldId id="258" r:id="rId5"/>
+    <p:sldId id="259" r:id="rId6"/>
+    <p:sldId id="260" r:id="rId7"/>
+    <p:sldId id="261" r:id="rId8"/>
+    <p:sldId id="262" r:id="rId9"/>
   </p:sldIdLst>
   <p:sldSz cx="12192000" cy="6858000"/>
   <p:notesSz cx="6858000" cy="9144000"/>
@@ -267,7 +268,7 @@
           <a:p>
             <a:fld id="{D38C393F-B997-4CF7-AD25-2687C8CBC838}" type="datetimeFigureOut">
               <a:rPr lang="en-US" smtClean="0"/>
-              <a:t>12/13/2025</a:t>
+              <a:t>1/15/2026</a:t>
             </a:fld>
             <a:endParaRPr lang="en-US"/>
           </a:p>
@@ -467,7 +468,7 @@
           <a:p>
             <a:fld id="{D38C393F-B997-4CF7-AD25-2687C8CBC838}" type="datetimeFigureOut">
               <a:rPr lang="en-US" smtClean="0"/>
-              <a:t>12/13/2025</a:t>
+              <a:t>1/15/2026</a:t>
             </a:fld>
             <a:endParaRPr lang="en-US"/>
           </a:p>
@@ -677,7 +678,7 @@
           <a:p>
             <a:fld id="{D38C393F-B997-4CF7-AD25-2687C8CBC838}" type="datetimeFigureOut">
               <a:rPr lang="en-US" smtClean="0"/>
-              <a:t>12/13/2025</a:t>
+              <a:t>1/15/2026</a:t>
             </a:fld>
             <a:endParaRPr lang="en-US"/>
           </a:p>
@@ -877,7 +878,7 @@
           <a:p>
             <a:fld id="{D38C393F-B997-4CF7-AD25-2687C8CBC838}" type="datetimeFigureOut">
               <a:rPr lang="en-US" smtClean="0"/>
-              <a:t>12/13/2025</a:t>
+              <a:t>1/15/2026</a:t>
             </a:fld>
             <a:endParaRPr lang="en-US"/>
           </a:p>
@@ -1153,7 +1154,7 @@
           <a:p>
             <a:fld id="{D38C393F-B997-4CF7-AD25-2687C8CBC838}" type="datetimeFigureOut">
               <a:rPr lang="en-US" smtClean="0"/>
-              <a:t>12/13/2025</a:t>
+              <a:t>1/15/2026</a:t>
             </a:fld>
             <a:endParaRPr lang="en-US"/>
           </a:p>
@@ -1421,7 +1422,7 @@
           <a:p>
             <a:fld id="{D38C393F-B997-4CF7-AD25-2687C8CBC838}" type="datetimeFigureOut">
               <a:rPr lang="en-US" smtClean="0"/>
-              <a:t>12/13/2025</a:t>
+              <a:t>1/15/2026</a:t>
             </a:fld>
             <a:endParaRPr lang="en-US"/>
           </a:p>
@@ -1836,7 +1837,7 @@
           <a:p>
             <a:fld id="{D38C393F-B997-4CF7-AD25-2687C8CBC838}" type="datetimeFigureOut">
               <a:rPr lang="en-US" smtClean="0"/>
-              <a:t>12/13/2025</a:t>
+              <a:t>1/15/2026</a:t>
             </a:fld>
             <a:endParaRPr lang="en-US"/>
           </a:p>
@@ -1978,7 +1979,7 @@
           <a:p>
             <a:fld id="{D38C393F-B997-4CF7-AD25-2687C8CBC838}" type="datetimeFigureOut">
               <a:rPr lang="en-US" smtClean="0"/>
-              <a:t>12/13/2025</a:t>
+              <a:t>1/15/2026</a:t>
             </a:fld>
             <a:endParaRPr lang="en-US"/>
           </a:p>
@@ -2091,7 +2092,7 @@
           <a:p>
             <a:fld id="{D38C393F-B997-4CF7-AD25-2687C8CBC838}" type="datetimeFigureOut">
               <a:rPr lang="en-US" smtClean="0"/>
-              <a:t>12/13/2025</a:t>
+              <a:t>1/15/2026</a:t>
             </a:fld>
             <a:endParaRPr lang="en-US"/>
           </a:p>
@@ -2404,7 +2405,7 @@
           <a:p>
             <a:fld id="{D38C393F-B997-4CF7-AD25-2687C8CBC838}" type="datetimeFigureOut">
               <a:rPr lang="en-US" smtClean="0"/>
-              <a:t>12/13/2025</a:t>
+              <a:t>1/15/2026</a:t>
             </a:fld>
             <a:endParaRPr lang="en-US"/>
           </a:p>
@@ -2693,7 +2694,7 @@
           <a:p>
             <a:fld id="{D38C393F-B997-4CF7-AD25-2687C8CBC838}" type="datetimeFigureOut">
               <a:rPr lang="en-US" smtClean="0"/>
-              <a:t>12/13/2025</a:t>
+              <a:t>1/15/2026</a:t>
             </a:fld>
             <a:endParaRPr lang="en-US"/>
           </a:p>
@@ -2936,7 +2937,7 @@
           <a:p>
             <a:fld id="{D38C393F-B997-4CF7-AD25-2687C8CBC838}" type="datetimeFigureOut">
               <a:rPr lang="en-US" smtClean="0"/>
-              <a:t>12/13/2025</a:t>
+              <a:t>1/15/2026</a:t>
             </a:fld>
             <a:endParaRPr lang="en-US"/>
           </a:p>
@@ -6397,6 +6398,1030 @@
       </p:grpSpPr>
       <p:sp>
         <p:nvSpPr>
+          <p:cNvPr id="4" name="Rectangle : coins arrondis 3">
+            <a:extLst>
+              <a:ext uri="{FF2B5EF4-FFF2-40B4-BE49-F238E27FC236}">
+                <a16:creationId xmlns:a16="http://schemas.microsoft.com/office/drawing/2014/main" id="{683337A6-0295-6FDC-2B0E-E02A1A0D1E65}"/>
+              </a:ext>
+            </a:extLst>
+          </p:cNvPr>
+          <p:cNvSpPr/>
+          <p:nvPr/>
+        </p:nvSpPr>
+        <p:spPr>
+          <a:xfrm>
+            <a:off x="1680519" y="556054"/>
+            <a:ext cx="6604686" cy="889687"/>
+          </a:xfrm>
+          <a:prstGeom prst="roundRect">
+            <a:avLst/>
+          </a:prstGeom>
+          <a:solidFill>
+            <a:schemeClr val="tx2">
+              <a:lumMod val="25000"/>
+              <a:lumOff val="75000"/>
+            </a:schemeClr>
+          </a:solidFill>
+        </p:spPr>
+        <p:style>
+          <a:lnRef idx="2">
+            <a:schemeClr val="accent1">
+              <a:shade val="15000"/>
+            </a:schemeClr>
+          </a:lnRef>
+          <a:fillRef idx="1">
+            <a:schemeClr val="accent1"/>
+          </a:fillRef>
+          <a:effectRef idx="0">
+            <a:schemeClr val="accent1"/>
+          </a:effectRef>
+          <a:fontRef idx="minor">
+            <a:schemeClr val="lt1"/>
+          </a:fontRef>
+        </p:style>
+        <p:txBody>
+          <a:bodyPr rtlCol="0" anchor="b"/>
+          <a:lstStyle/>
+          <a:p>
+            <a:pPr algn="ctr"/>
+            <a:r>
+              <a:rPr lang="fr-FR" sz="1400" dirty="0" err="1"/>
+              <a:t>Here</a:t>
+            </a:r>
+            <a:r>
+              <a:rPr lang="fr-FR" sz="1400" dirty="0"/>
+              <a:t> </a:t>
+            </a:r>
+            <a:r>
+              <a:rPr lang="fr-FR" sz="1400" dirty="0" err="1"/>
+              <a:t>we</a:t>
+            </a:r>
+            <a:r>
+              <a:rPr lang="fr-FR" sz="1400" dirty="0"/>
+              <a:t> have, </a:t>
+            </a:r>
+            <a:r>
+              <a:rPr lang="fr-FR" sz="1400" dirty="0" err="1"/>
+              <a:t>name</a:t>
+            </a:r>
+            <a:r>
+              <a:rPr lang="fr-FR" sz="1400" dirty="0"/>
+              <a:t>, description, </a:t>
+            </a:r>
+            <a:r>
+              <a:rPr lang="fr-FR" sz="1400" dirty="0" err="1"/>
+              <a:t>category</a:t>
+            </a:r>
+            <a:r>
+              <a:rPr lang="fr-FR" sz="1400" dirty="0"/>
+              <a:t> and permissions</a:t>
+            </a:r>
+            <a:endParaRPr lang="en-US" sz="1400" dirty="0"/>
+          </a:p>
+        </p:txBody>
+      </p:sp>
+      <p:sp>
+        <p:nvSpPr>
+          <p:cNvPr id="5" name="ZoneTexte 4">
+            <a:extLst>
+              <a:ext uri="{FF2B5EF4-FFF2-40B4-BE49-F238E27FC236}">
+                <a16:creationId xmlns:a16="http://schemas.microsoft.com/office/drawing/2014/main" id="{DA521EC9-2125-192D-6350-03841D981F80}"/>
+              </a:ext>
+            </a:extLst>
+          </p:cNvPr>
+          <p:cNvSpPr txBox="1"/>
+          <p:nvPr/>
+        </p:nvSpPr>
+        <p:spPr>
+          <a:xfrm>
+            <a:off x="2063579" y="327454"/>
+            <a:ext cx="3554178" cy="369332"/>
+          </a:xfrm>
+          <a:prstGeom prst="rect">
+            <a:avLst/>
+          </a:prstGeom>
+          <a:solidFill>
+            <a:schemeClr val="bg1"/>
+          </a:solidFill>
+        </p:spPr>
+        <p:txBody>
+          <a:bodyPr wrap="none" rtlCol="0">
+            <a:spAutoFit/>
+          </a:bodyPr>
+          <a:lstStyle/>
+          <a:p>
+            <a:r>
+              <a:rPr lang="fr-FR" dirty="0"/>
+              <a:t>1 - </a:t>
+            </a:r>
+            <a:r>
+              <a:rPr lang="fr-FR" dirty="0" err="1"/>
+              <a:t>What</a:t>
+            </a:r>
+            <a:r>
+              <a:rPr lang="fr-FR" dirty="0"/>
+              <a:t> </a:t>
+            </a:r>
+            <a:r>
+              <a:rPr lang="fr-FR" dirty="0" err="1"/>
+              <a:t>is</a:t>
+            </a:r>
+            <a:r>
+              <a:rPr lang="fr-FR" dirty="0"/>
+              <a:t> the </a:t>
+            </a:r>
+            <a:r>
+              <a:rPr lang="fr-FR" dirty="0" err="1"/>
+              <a:t>purpose</a:t>
+            </a:r>
+            <a:r>
+              <a:rPr lang="fr-FR" dirty="0"/>
+              <a:t> of </a:t>
+            </a:r>
+            <a:r>
+              <a:rPr lang="fr-FR" dirty="0" err="1"/>
+              <a:t>this</a:t>
+            </a:r>
+            <a:r>
+              <a:rPr lang="fr-FR" dirty="0"/>
+              <a:t> </a:t>
+            </a:r>
+            <a:r>
+              <a:rPr lang="fr-FR" dirty="0" err="1"/>
+              <a:t>tool</a:t>
+            </a:r>
+            <a:endParaRPr lang="en-US" dirty="0"/>
+          </a:p>
+        </p:txBody>
+      </p:sp>
+      <p:sp>
+        <p:nvSpPr>
+          <p:cNvPr id="6" name="Rectangle : coins arrondis 5">
+            <a:extLst>
+              <a:ext uri="{FF2B5EF4-FFF2-40B4-BE49-F238E27FC236}">
+                <a16:creationId xmlns:a16="http://schemas.microsoft.com/office/drawing/2014/main" id="{6C80CDF9-ACF9-9C68-35A7-728FBD68D7CD}"/>
+              </a:ext>
+            </a:extLst>
+          </p:cNvPr>
+          <p:cNvSpPr/>
+          <p:nvPr/>
+        </p:nvSpPr>
+        <p:spPr>
+          <a:xfrm>
+            <a:off x="1680519" y="1538417"/>
+            <a:ext cx="6604686" cy="2026508"/>
+          </a:xfrm>
+          <a:prstGeom prst="roundRect">
+            <a:avLst/>
+          </a:prstGeom>
+          <a:solidFill>
+            <a:schemeClr val="tx2">
+              <a:lumMod val="25000"/>
+              <a:lumOff val="75000"/>
+            </a:schemeClr>
+          </a:solidFill>
+        </p:spPr>
+        <p:style>
+          <a:lnRef idx="2">
+            <a:schemeClr val="accent1">
+              <a:shade val="15000"/>
+            </a:schemeClr>
+          </a:lnRef>
+          <a:fillRef idx="1">
+            <a:schemeClr val="accent1"/>
+          </a:fillRef>
+          <a:effectRef idx="0">
+            <a:schemeClr val="accent1"/>
+          </a:effectRef>
+          <a:fontRef idx="minor">
+            <a:schemeClr val="lt1"/>
+          </a:fontRef>
+        </p:style>
+        <p:txBody>
+          <a:bodyPr rtlCol="0" anchor="b"/>
+          <a:lstStyle/>
+          <a:p>
+            <a:pPr algn="ctr"/>
+            <a:r>
+              <a:rPr lang="fr-FR" sz="1400" dirty="0" err="1"/>
+              <a:t>Here</a:t>
+            </a:r>
+            <a:r>
+              <a:rPr lang="fr-FR" sz="1400" dirty="0"/>
+              <a:t> </a:t>
+            </a:r>
+            <a:r>
+              <a:rPr lang="fr-FR" sz="1400" dirty="0" err="1"/>
+              <a:t>we</a:t>
+            </a:r>
+            <a:r>
+              <a:rPr lang="fr-FR" sz="1400" dirty="0"/>
+              <a:t> drop MCP servers. Update to </a:t>
+            </a:r>
+            <a:r>
+              <a:rPr lang="fr-FR" sz="1400" dirty="0" err="1"/>
+              <a:t>current</a:t>
+            </a:r>
+            <a:r>
+              <a:rPr lang="fr-FR" sz="1400" dirty="0"/>
+              <a:t> situation: </a:t>
+            </a:r>
+            <a:r>
+              <a:rPr lang="fr-FR" sz="1400" dirty="0" err="1"/>
+              <a:t>instead</a:t>
+            </a:r>
+            <a:r>
+              <a:rPr lang="fr-FR" sz="1400" dirty="0"/>
+              <a:t> of </a:t>
+            </a:r>
+            <a:r>
+              <a:rPr lang="fr-FR" sz="1400" dirty="0" err="1"/>
+              <a:t>displaying</a:t>
+            </a:r>
+            <a:r>
+              <a:rPr lang="fr-FR" sz="1400" dirty="0"/>
+              <a:t> an MCP server </a:t>
+            </a:r>
+            <a:r>
+              <a:rPr lang="fr-FR" sz="1400" dirty="0" err="1"/>
+              <a:t>with</a:t>
+            </a:r>
+            <a:r>
+              <a:rPr lang="fr-FR" sz="1400" dirty="0"/>
+              <a:t> the </a:t>
+            </a:r>
+            <a:r>
+              <a:rPr lang="fr-FR" sz="1400" dirty="0" err="1"/>
+              <a:t>list</a:t>
+            </a:r>
+            <a:r>
+              <a:rPr lang="fr-FR" sz="1400" dirty="0"/>
+              <a:t> of all </a:t>
+            </a:r>
+            <a:r>
+              <a:rPr lang="fr-FR" sz="1400" dirty="0" err="1"/>
+              <a:t>its</a:t>
+            </a:r>
+            <a:r>
+              <a:rPr lang="fr-FR" sz="1400" dirty="0"/>
+              <a:t> </a:t>
+            </a:r>
+            <a:r>
+              <a:rPr lang="fr-FR" sz="1400" dirty="0" err="1"/>
+              <a:t>tools</a:t>
+            </a:r>
+            <a:r>
+              <a:rPr lang="fr-FR" sz="1400" dirty="0"/>
+              <a:t>, </a:t>
+            </a:r>
+            <a:r>
+              <a:rPr lang="fr-FR" sz="1400" dirty="0" err="1"/>
+              <a:t>we</a:t>
+            </a:r>
+            <a:r>
+              <a:rPr lang="fr-FR" sz="1400" dirty="0"/>
+              <a:t> </a:t>
+            </a:r>
+            <a:r>
+              <a:rPr lang="fr-FR" sz="1400" dirty="0" err="1"/>
+              <a:t>would</a:t>
+            </a:r>
+            <a:r>
+              <a:rPr lang="fr-FR" sz="1400" dirty="0"/>
+              <a:t>:</a:t>
+            </a:r>
+          </a:p>
+          <a:p>
+            <a:pPr algn="ctr"/>
+            <a:r>
+              <a:rPr lang="fr-FR" sz="1400" dirty="0"/>
+              <a:t>1 – </a:t>
+            </a:r>
+            <a:r>
+              <a:rPr lang="fr-FR" sz="1400" dirty="0" err="1"/>
+              <a:t>Allow</a:t>
+            </a:r>
+            <a:r>
+              <a:rPr lang="fr-FR" sz="1400" dirty="0"/>
+              <a:t> to drop </a:t>
+            </a:r>
+            <a:r>
+              <a:rPr lang="fr-FR" sz="1400" dirty="0" err="1"/>
+              <a:t>several</a:t>
+            </a:r>
+            <a:r>
+              <a:rPr lang="fr-FR" sz="1400" dirty="0"/>
+              <a:t> MCP servers. So </a:t>
+            </a:r>
+            <a:r>
+              <a:rPr lang="fr-FR" sz="1400" dirty="0" err="1"/>
+              <a:t>we</a:t>
+            </a:r>
+            <a:r>
+              <a:rPr lang="fr-FR" sz="1400" dirty="0"/>
+              <a:t> </a:t>
+            </a:r>
+            <a:r>
+              <a:rPr lang="fr-FR" sz="1400" dirty="0" err="1"/>
+              <a:t>need</a:t>
+            </a:r>
+            <a:r>
+              <a:rPr lang="fr-FR" sz="1400" dirty="0"/>
+              <a:t> « </a:t>
+            </a:r>
+            <a:r>
+              <a:rPr lang="fr-FR" sz="1400" dirty="0" err="1"/>
+              <a:t>placeholders</a:t>
+            </a:r>
+            <a:r>
+              <a:rPr lang="fr-FR" sz="1400" dirty="0"/>
+              <a:t> » </a:t>
+            </a:r>
+            <a:r>
+              <a:rPr lang="fr-FR" sz="1400" dirty="0" err="1"/>
+              <a:t>so</a:t>
+            </a:r>
+            <a:r>
+              <a:rPr lang="fr-FR" sz="1400" dirty="0"/>
+              <a:t> the user </a:t>
+            </a:r>
+            <a:r>
+              <a:rPr lang="fr-FR" sz="1400" dirty="0" err="1"/>
+              <a:t>understands</a:t>
+            </a:r>
+            <a:r>
+              <a:rPr lang="fr-FR" sz="1400" dirty="0"/>
+              <a:t> </a:t>
+            </a:r>
+            <a:r>
+              <a:rPr lang="fr-FR" sz="1400" dirty="0" err="1"/>
+              <a:t>he</a:t>
+            </a:r>
+            <a:r>
+              <a:rPr lang="fr-FR" sz="1400" dirty="0"/>
+              <a:t> can drop </a:t>
+            </a:r>
+            <a:r>
+              <a:rPr lang="fr-FR" sz="1400" dirty="0" err="1"/>
+              <a:t>other</a:t>
+            </a:r>
+            <a:r>
+              <a:rPr lang="fr-FR" sz="1400" dirty="0"/>
+              <a:t> MCP Servers</a:t>
+            </a:r>
+          </a:p>
+          <a:p>
+            <a:pPr algn="ctr"/>
+            <a:r>
+              <a:rPr lang="fr-FR" sz="1400" dirty="0"/>
+              <a:t>2 – </a:t>
+            </a:r>
+            <a:r>
+              <a:rPr lang="fr-FR" sz="1400" dirty="0" err="1"/>
+              <a:t>Each</a:t>
+            </a:r>
+            <a:r>
+              <a:rPr lang="fr-FR" sz="1400" dirty="0"/>
+              <a:t> « MCP server box » must display </a:t>
+            </a:r>
+            <a:r>
+              <a:rPr lang="fr-FR" sz="1400" dirty="0" err="1"/>
+              <a:t>only</a:t>
+            </a:r>
+            <a:r>
+              <a:rPr lang="fr-FR" sz="1400" dirty="0"/>
+              <a:t> the </a:t>
+            </a:r>
+            <a:r>
+              <a:rPr lang="fr-FR" sz="1400" dirty="0" err="1"/>
+              <a:t>name</a:t>
+            </a:r>
+            <a:r>
+              <a:rPr lang="fr-FR" sz="1400" dirty="0"/>
+              <a:t> of the MCP server and the </a:t>
+            </a:r>
+            <a:r>
+              <a:rPr lang="fr-FR" sz="1400" dirty="0" err="1"/>
+              <a:t>selected</a:t>
+            </a:r>
+            <a:r>
+              <a:rPr lang="fr-FR" sz="1400" dirty="0"/>
+              <a:t> </a:t>
+            </a:r>
+            <a:r>
+              <a:rPr lang="fr-FR" sz="1400" dirty="0" err="1"/>
+              <a:t>tools</a:t>
+            </a:r>
+            <a:r>
+              <a:rPr lang="fr-FR" sz="1400" dirty="0"/>
+              <a:t> (not all the </a:t>
+            </a:r>
+            <a:r>
+              <a:rPr lang="fr-FR" sz="1400" dirty="0" err="1"/>
+              <a:t>list</a:t>
+            </a:r>
+            <a:r>
+              <a:rPr lang="fr-FR" sz="1400" dirty="0"/>
+              <a:t> of </a:t>
+            </a:r>
+            <a:r>
+              <a:rPr lang="fr-FR" sz="1400" dirty="0" err="1"/>
+              <a:t>tools</a:t>
+            </a:r>
+            <a:r>
+              <a:rPr lang="fr-FR" sz="1400" dirty="0"/>
+              <a:t>), </a:t>
+            </a:r>
+            <a:r>
+              <a:rPr lang="fr-FR" sz="1400" dirty="0" err="1"/>
+              <a:t>with</a:t>
+            </a:r>
+            <a:r>
+              <a:rPr lang="fr-FR" sz="1400" dirty="0"/>
+              <a:t> a </a:t>
+            </a:r>
+            <a:r>
+              <a:rPr lang="fr-FR" sz="1400" dirty="0" err="1"/>
+              <a:t>way</a:t>
+            </a:r>
+            <a:r>
+              <a:rPr lang="fr-FR" sz="1400" dirty="0"/>
+              <a:t> to expand the </a:t>
+            </a:r>
+            <a:r>
+              <a:rPr lang="fr-FR" sz="1400" dirty="0" err="1"/>
+              <a:t>list</a:t>
+            </a:r>
+            <a:r>
+              <a:rPr lang="fr-FR" sz="1400" dirty="0"/>
+              <a:t> in </a:t>
+            </a:r>
+            <a:r>
+              <a:rPr lang="fr-FR" sz="1400" dirty="0" err="1"/>
+              <a:t>order</a:t>
+            </a:r>
+            <a:r>
+              <a:rPr lang="fr-FR" sz="1400" dirty="0"/>
+              <a:t> to select more if </a:t>
+            </a:r>
+            <a:r>
+              <a:rPr lang="fr-FR" sz="1400" dirty="0" err="1"/>
+              <a:t>needed</a:t>
+            </a:r>
+            <a:endParaRPr lang="en-US" sz="1400" dirty="0"/>
+          </a:p>
+        </p:txBody>
+      </p:sp>
+      <p:sp>
+        <p:nvSpPr>
+          <p:cNvPr id="7" name="ZoneTexte 6">
+            <a:extLst>
+              <a:ext uri="{FF2B5EF4-FFF2-40B4-BE49-F238E27FC236}">
+                <a16:creationId xmlns:a16="http://schemas.microsoft.com/office/drawing/2014/main" id="{1F49B09D-BEB0-71B5-9EFE-506D265705DC}"/>
+              </a:ext>
+            </a:extLst>
+          </p:cNvPr>
+          <p:cNvSpPr txBox="1"/>
+          <p:nvPr/>
+        </p:nvSpPr>
+        <p:spPr>
+          <a:xfrm>
+            <a:off x="2050233" y="1489674"/>
+            <a:ext cx="2222853" cy="369332"/>
+          </a:xfrm>
+          <a:prstGeom prst="rect">
+            <a:avLst/>
+          </a:prstGeom>
+          <a:solidFill>
+            <a:schemeClr val="bg1"/>
+          </a:solidFill>
+        </p:spPr>
+        <p:txBody>
+          <a:bodyPr wrap="none" rtlCol="0">
+            <a:spAutoFit/>
+          </a:bodyPr>
+          <a:lstStyle/>
+          <a:p>
+            <a:r>
+              <a:rPr lang="fr-FR" dirty="0"/>
+              <a:t>2 – Select MCP Tools</a:t>
+            </a:r>
+            <a:endParaRPr lang="en-US" dirty="0"/>
+          </a:p>
+        </p:txBody>
+      </p:sp>
+      <p:sp>
+        <p:nvSpPr>
+          <p:cNvPr id="8" name="Rectangle : coins arrondis 7">
+            <a:extLst>
+              <a:ext uri="{FF2B5EF4-FFF2-40B4-BE49-F238E27FC236}">
+                <a16:creationId xmlns:a16="http://schemas.microsoft.com/office/drawing/2014/main" id="{6D303C96-A57C-4CD8-EA74-211CFB296090}"/>
+              </a:ext>
+            </a:extLst>
+          </p:cNvPr>
+          <p:cNvSpPr/>
+          <p:nvPr/>
+        </p:nvSpPr>
+        <p:spPr>
+          <a:xfrm>
+            <a:off x="1680519" y="3793524"/>
+            <a:ext cx="6604686" cy="1390135"/>
+          </a:xfrm>
+          <a:prstGeom prst="roundRect">
+            <a:avLst/>
+          </a:prstGeom>
+          <a:solidFill>
+            <a:schemeClr val="tx2">
+              <a:lumMod val="25000"/>
+              <a:lumOff val="75000"/>
+            </a:schemeClr>
+          </a:solidFill>
+        </p:spPr>
+        <p:style>
+          <a:lnRef idx="2">
+            <a:schemeClr val="accent1">
+              <a:shade val="15000"/>
+            </a:schemeClr>
+          </a:lnRef>
+          <a:fillRef idx="1">
+            <a:schemeClr val="accent1"/>
+          </a:fillRef>
+          <a:effectRef idx="0">
+            <a:schemeClr val="accent1"/>
+          </a:effectRef>
+          <a:fontRef idx="minor">
+            <a:schemeClr val="lt1"/>
+          </a:fontRef>
+        </p:style>
+        <p:txBody>
+          <a:bodyPr rtlCol="0" anchor="b"/>
+          <a:lstStyle/>
+          <a:p>
+            <a:pPr algn="ctr"/>
+            <a:r>
+              <a:rPr lang="fr-FR" sz="1400" dirty="0" err="1"/>
+              <a:t>Here</a:t>
+            </a:r>
+            <a:r>
+              <a:rPr lang="fr-FR" sz="1400" dirty="0"/>
+              <a:t> </a:t>
+            </a:r>
+            <a:r>
+              <a:rPr lang="fr-FR" sz="1400" dirty="0" err="1"/>
+              <a:t>we</a:t>
+            </a:r>
+            <a:r>
+              <a:rPr lang="fr-FR" sz="1400" dirty="0"/>
+              <a:t> display the </a:t>
+            </a:r>
+            <a:r>
+              <a:rPr lang="fr-FR" sz="1400" dirty="0" err="1"/>
+              <a:t>execution</a:t>
+            </a:r>
+            <a:r>
+              <a:rPr lang="fr-FR" sz="1400" dirty="0"/>
+              <a:t> pipeline in a </a:t>
+            </a:r>
+            <a:r>
+              <a:rPr lang="fr-FR" sz="1400" dirty="0" err="1"/>
+              <a:t>nice</a:t>
+            </a:r>
+            <a:r>
+              <a:rPr lang="fr-FR" sz="1400" dirty="0"/>
+              <a:t> </a:t>
+            </a:r>
+            <a:r>
+              <a:rPr lang="fr-FR" sz="1400" dirty="0" err="1"/>
+              <a:t>graphical</a:t>
+            </a:r>
+            <a:r>
+              <a:rPr lang="fr-FR" sz="1400" dirty="0"/>
+              <a:t> </a:t>
+            </a:r>
+            <a:r>
+              <a:rPr lang="fr-FR" sz="1400" dirty="0" err="1"/>
+              <a:t>way</a:t>
+            </a:r>
+            <a:r>
+              <a:rPr lang="fr-FR" sz="1400" dirty="0"/>
+              <a:t>, </a:t>
+            </a:r>
+            <a:r>
+              <a:rPr lang="fr-FR" sz="1400" dirty="0" err="1"/>
+              <a:t>starting</a:t>
+            </a:r>
+            <a:r>
+              <a:rPr lang="fr-FR" sz="1400" dirty="0"/>
+              <a:t> </a:t>
+            </a:r>
+            <a:r>
+              <a:rPr lang="fr-FR" sz="1400" dirty="0" err="1"/>
+              <a:t>with</a:t>
+            </a:r>
+            <a:r>
+              <a:rPr lang="fr-FR" sz="1400" dirty="0"/>
+              <a:t> the input, </a:t>
+            </a:r>
+            <a:r>
+              <a:rPr lang="fr-FR" sz="1400" dirty="0" err="1"/>
+              <a:t>each</a:t>
+            </a:r>
+            <a:r>
+              <a:rPr lang="fr-FR" sz="1400" dirty="0"/>
+              <a:t> </a:t>
+            </a:r>
+            <a:r>
+              <a:rPr lang="fr-FR" sz="1400" dirty="0" err="1"/>
+              <a:t>step</a:t>
+            </a:r>
+            <a:r>
+              <a:rPr lang="fr-FR" sz="1400" dirty="0"/>
+              <a:t> and the output </a:t>
+            </a:r>
+            <a:r>
+              <a:rPr lang="fr-FR" sz="1400" dirty="0" err="1"/>
+              <a:t>with</a:t>
+            </a:r>
+            <a:r>
+              <a:rPr lang="fr-FR" sz="1400" dirty="0"/>
+              <a:t> the </a:t>
+            </a:r>
+            <a:r>
+              <a:rPr lang="fr-FR" sz="1400" dirty="0" err="1"/>
+              <a:t>ability</a:t>
+            </a:r>
+            <a:r>
+              <a:rPr lang="fr-FR" sz="1400" dirty="0"/>
+              <a:t> to display and </a:t>
+            </a:r>
+            <a:r>
+              <a:rPr lang="fr-FR" sz="1400" dirty="0" err="1"/>
+              <a:t>edit</a:t>
+            </a:r>
+            <a:r>
+              <a:rPr lang="fr-FR" sz="1400" dirty="0"/>
+              <a:t> the JSON by </a:t>
+            </a:r>
+            <a:r>
+              <a:rPr lang="fr-FR" sz="1400" dirty="0" err="1"/>
+              <a:t>clicking</a:t>
+            </a:r>
+            <a:r>
+              <a:rPr lang="fr-FR" sz="1400" dirty="0"/>
+              <a:t> on </a:t>
+            </a:r>
+            <a:r>
+              <a:rPr lang="fr-FR" sz="1400" dirty="0" err="1"/>
+              <a:t>each</a:t>
+            </a:r>
+            <a:r>
+              <a:rPr lang="fr-FR" sz="1400" dirty="0"/>
+              <a:t> « </a:t>
+            </a:r>
+            <a:r>
+              <a:rPr lang="fr-FR" sz="1400" dirty="0" err="1"/>
+              <a:t>node</a:t>
+            </a:r>
+            <a:r>
+              <a:rPr lang="fr-FR" sz="1400" dirty="0"/>
+              <a:t> ». </a:t>
+            </a:r>
+            <a:r>
+              <a:rPr lang="fr-FR" sz="1400" dirty="0" err="1"/>
+              <a:t>We</a:t>
+            </a:r>
+            <a:r>
+              <a:rPr lang="fr-FR" sz="1400" dirty="0"/>
+              <a:t> </a:t>
+            </a:r>
+            <a:r>
+              <a:rPr lang="fr-FR" sz="1400" dirty="0" err="1"/>
+              <a:t>still</a:t>
+            </a:r>
+            <a:r>
+              <a:rPr lang="fr-FR" sz="1400" dirty="0"/>
+              <a:t> have the « </a:t>
+            </a:r>
+            <a:r>
+              <a:rPr lang="fr-FR" sz="1400" dirty="0" err="1"/>
+              <a:t>Generate</a:t>
+            </a:r>
+            <a:r>
+              <a:rPr lang="fr-FR" sz="1400" dirty="0"/>
+              <a:t> pipeline » and « </a:t>
+            </a:r>
+            <a:r>
+              <a:rPr lang="fr-FR" sz="1400" dirty="0" err="1"/>
+              <a:t>Verify</a:t>
+            </a:r>
+            <a:r>
+              <a:rPr lang="fr-FR" sz="1400" dirty="0"/>
+              <a:t> pipeline »</a:t>
+            </a:r>
+            <a:endParaRPr lang="en-US" sz="1400" dirty="0"/>
+          </a:p>
+        </p:txBody>
+      </p:sp>
+      <p:sp>
+        <p:nvSpPr>
+          <p:cNvPr id="9" name="ZoneTexte 8">
+            <a:extLst>
+              <a:ext uri="{FF2B5EF4-FFF2-40B4-BE49-F238E27FC236}">
+                <a16:creationId xmlns:a16="http://schemas.microsoft.com/office/drawing/2014/main" id="{1AFFA084-E305-7FE5-9C8F-03170ABEDA96}"/>
+              </a:ext>
+            </a:extLst>
+          </p:cNvPr>
+          <p:cNvSpPr txBox="1"/>
+          <p:nvPr/>
+        </p:nvSpPr>
+        <p:spPr>
+          <a:xfrm>
+            <a:off x="1940011" y="3599932"/>
+            <a:ext cx="2443298" cy="369332"/>
+          </a:xfrm>
+          <a:prstGeom prst="rect">
+            <a:avLst/>
+          </a:prstGeom>
+          <a:solidFill>
+            <a:schemeClr val="bg1"/>
+          </a:solidFill>
+        </p:spPr>
+        <p:txBody>
+          <a:bodyPr wrap="none" rtlCol="0">
+            <a:spAutoFit/>
+          </a:bodyPr>
+          <a:lstStyle/>
+          <a:p>
+            <a:r>
+              <a:rPr lang="fr-FR" dirty="0"/>
+              <a:t>3 – </a:t>
+            </a:r>
+            <a:r>
+              <a:rPr lang="fr-FR" dirty="0" err="1"/>
+              <a:t>Implement</a:t>
+            </a:r>
+            <a:r>
+              <a:rPr lang="fr-FR" dirty="0"/>
+              <a:t> Pipeline</a:t>
+            </a:r>
+            <a:endParaRPr lang="en-US" dirty="0"/>
+          </a:p>
+        </p:txBody>
+      </p:sp>
+      <p:sp>
+        <p:nvSpPr>
+          <p:cNvPr id="10" name="Rectangle : coins arrondis 9">
+            <a:extLst>
+              <a:ext uri="{FF2B5EF4-FFF2-40B4-BE49-F238E27FC236}">
+                <a16:creationId xmlns:a16="http://schemas.microsoft.com/office/drawing/2014/main" id="{9BDAC12D-9253-2B76-D85B-AE21AE02D186}"/>
+              </a:ext>
+            </a:extLst>
+          </p:cNvPr>
+          <p:cNvSpPr/>
+          <p:nvPr/>
+        </p:nvSpPr>
+        <p:spPr>
+          <a:xfrm>
+            <a:off x="1680519" y="5377251"/>
+            <a:ext cx="6604686" cy="1390135"/>
+          </a:xfrm>
+          <a:prstGeom prst="roundRect">
+            <a:avLst/>
+          </a:prstGeom>
+          <a:solidFill>
+            <a:schemeClr val="tx2">
+              <a:lumMod val="25000"/>
+              <a:lumOff val="75000"/>
+            </a:schemeClr>
+          </a:solidFill>
+        </p:spPr>
+        <p:style>
+          <a:lnRef idx="2">
+            <a:schemeClr val="accent1">
+              <a:shade val="15000"/>
+            </a:schemeClr>
+          </a:lnRef>
+          <a:fillRef idx="1">
+            <a:schemeClr val="accent1"/>
+          </a:fillRef>
+          <a:effectRef idx="0">
+            <a:schemeClr val="accent1"/>
+          </a:effectRef>
+          <a:fontRef idx="minor">
+            <a:schemeClr val="lt1"/>
+          </a:fontRef>
+        </p:style>
+        <p:txBody>
+          <a:bodyPr rtlCol="0" anchor="b"/>
+          <a:lstStyle/>
+          <a:p>
+            <a:pPr algn="ctr"/>
+            <a:r>
+              <a:rPr lang="fr-FR" sz="1400" dirty="0"/>
+              <a:t>This </a:t>
+            </a:r>
+            <a:r>
+              <a:rPr lang="fr-FR" sz="1400" dirty="0" err="1"/>
+              <a:t>is</a:t>
+            </a:r>
+            <a:r>
+              <a:rPr lang="fr-FR" sz="1400" dirty="0"/>
+              <a:t> the « </a:t>
+            </a:r>
+            <a:r>
+              <a:rPr lang="fr-FR" sz="1400" dirty="0" err="1"/>
+              <a:t>Execute</a:t>
+            </a:r>
+            <a:r>
+              <a:rPr lang="fr-FR" sz="1400" dirty="0"/>
+              <a:t> » part. It </a:t>
+            </a:r>
+            <a:r>
+              <a:rPr lang="fr-FR" sz="1400" dirty="0" err="1"/>
+              <a:t>should</a:t>
+            </a:r>
+            <a:r>
+              <a:rPr lang="fr-FR" sz="1400" dirty="0"/>
+              <a:t> tell </a:t>
+            </a:r>
+            <a:r>
+              <a:rPr lang="fr-FR" sz="1400" dirty="0" err="1"/>
+              <a:t>that</a:t>
+            </a:r>
+            <a:r>
+              <a:rPr lang="fr-FR" sz="1400" dirty="0"/>
+              <a:t> one can </a:t>
+            </a:r>
+            <a:r>
+              <a:rPr lang="fr-FR" sz="1400" dirty="0" err="1"/>
+              <a:t>only</a:t>
+            </a:r>
+            <a:r>
+              <a:rPr lang="fr-FR" sz="1400" dirty="0"/>
+              <a:t> </a:t>
+            </a:r>
+            <a:r>
+              <a:rPr lang="fr-FR" sz="1400" dirty="0" err="1"/>
+              <a:t>execute</a:t>
+            </a:r>
+            <a:r>
+              <a:rPr lang="fr-FR" sz="1400" dirty="0"/>
+              <a:t> if the pipeline has been </a:t>
+            </a:r>
+            <a:r>
+              <a:rPr lang="fr-FR" sz="1400" dirty="0" err="1"/>
+              <a:t>successfully</a:t>
+            </a:r>
+            <a:r>
+              <a:rPr lang="fr-FR" sz="1400" dirty="0"/>
+              <a:t> </a:t>
+            </a:r>
+            <a:r>
+              <a:rPr lang="fr-FR" sz="1400" dirty="0" err="1"/>
+              <a:t>verified</a:t>
+            </a:r>
+            <a:r>
+              <a:rPr lang="fr-FR" sz="1400" dirty="0"/>
+              <a:t>. And </a:t>
+            </a:r>
+            <a:r>
+              <a:rPr lang="fr-FR" sz="1400" dirty="0" err="1"/>
+              <a:t>that</a:t>
+            </a:r>
+            <a:r>
+              <a:rPr lang="fr-FR" sz="1400" dirty="0"/>
+              <a:t> section </a:t>
+            </a:r>
+            <a:r>
+              <a:rPr lang="fr-FR" sz="1400" dirty="0" err="1"/>
+              <a:t>activates</a:t>
+            </a:r>
+            <a:r>
+              <a:rPr lang="fr-FR" sz="1400" dirty="0"/>
+              <a:t> / </a:t>
+            </a:r>
+            <a:r>
+              <a:rPr lang="fr-FR" sz="1400" dirty="0" err="1"/>
+              <a:t>deactives</a:t>
+            </a:r>
+            <a:r>
+              <a:rPr lang="fr-FR" sz="1400" dirty="0"/>
+              <a:t> </a:t>
+            </a:r>
+            <a:r>
+              <a:rPr lang="fr-FR" sz="1400" dirty="0" err="1"/>
+              <a:t>accordingly</a:t>
+            </a:r>
+            <a:r>
+              <a:rPr lang="fr-FR" sz="1400" dirty="0"/>
+              <a:t> </a:t>
+            </a:r>
+            <a:r>
+              <a:rPr lang="fr-FR" sz="1400" dirty="0" err="1"/>
+              <a:t>based</a:t>
+            </a:r>
+            <a:r>
+              <a:rPr lang="fr-FR" sz="1400" dirty="0"/>
+              <a:t> on the </a:t>
+            </a:r>
+            <a:r>
+              <a:rPr lang="fr-FR" sz="1400" dirty="0" err="1"/>
+              <a:t>success</a:t>
+            </a:r>
+            <a:r>
+              <a:rPr lang="fr-FR" sz="1400" dirty="0"/>
+              <a:t> </a:t>
+            </a:r>
+            <a:r>
+              <a:rPr lang="fr-FR" sz="1400" dirty="0" err="1"/>
+              <a:t>status</a:t>
+            </a:r>
+            <a:r>
+              <a:rPr lang="fr-FR" sz="1400" dirty="0"/>
+              <a:t> of the pipeline </a:t>
+            </a:r>
+            <a:r>
+              <a:rPr lang="fr-FR" sz="1400" dirty="0" err="1"/>
+              <a:t>verification</a:t>
+            </a:r>
+            <a:r>
+              <a:rPr lang="fr-FR" sz="1400" dirty="0"/>
+              <a:t>.</a:t>
+            </a:r>
+            <a:endParaRPr lang="en-US" sz="1400" dirty="0"/>
+          </a:p>
+        </p:txBody>
+      </p:sp>
+      <p:sp>
+        <p:nvSpPr>
+          <p:cNvPr id="11" name="ZoneTexte 10">
+            <a:extLst>
+              <a:ext uri="{FF2B5EF4-FFF2-40B4-BE49-F238E27FC236}">
+                <a16:creationId xmlns:a16="http://schemas.microsoft.com/office/drawing/2014/main" id="{FCDA5188-8A9B-2690-8E29-D5A1D1527023}"/>
+              </a:ext>
+            </a:extLst>
+          </p:cNvPr>
+          <p:cNvSpPr txBox="1"/>
+          <p:nvPr/>
+        </p:nvSpPr>
+        <p:spPr>
+          <a:xfrm>
+            <a:off x="1940011" y="5183659"/>
+            <a:ext cx="2108526" cy="369332"/>
+          </a:xfrm>
+          <a:prstGeom prst="rect">
+            <a:avLst/>
+          </a:prstGeom>
+          <a:solidFill>
+            <a:schemeClr val="bg1"/>
+          </a:solidFill>
+        </p:spPr>
+        <p:txBody>
+          <a:bodyPr wrap="none" rtlCol="0">
+            <a:spAutoFit/>
+          </a:bodyPr>
+          <a:lstStyle/>
+          <a:p>
+            <a:r>
+              <a:rPr lang="fr-FR" dirty="0"/>
+              <a:t>4 – Dry-run Pipeline</a:t>
+            </a:r>
+            <a:endParaRPr lang="en-US" dirty="0"/>
+          </a:p>
+        </p:txBody>
+      </p:sp>
+    </p:spTree>
+    <p:extLst>
+      <p:ext uri="{BB962C8B-B14F-4D97-AF65-F5344CB8AC3E}">
+        <p14:creationId xmlns:p14="http://schemas.microsoft.com/office/powerpoint/2010/main" val="2774954653"/>
+      </p:ext>
+    </p:extLst>
+  </p:cSld>
+  <p:clrMapOvr>
+    <a:masterClrMapping/>
+  </p:clrMapOvr>
+</p:sld>
+</file>
+
+<file path=ppt/slides/slide3.xml><?xml version="1.0" encoding="utf-8"?>
+<p:sld xmlns:a="http://schemas.openxmlformats.org/drawingml/2006/main" xmlns:r="http://schemas.openxmlformats.org/officeDocument/2006/relationships" xmlns:p="http://schemas.openxmlformats.org/presentationml/2006/main">
+  <p:cSld>
+    <p:spTree>
+      <p:nvGrpSpPr>
+        <p:cNvPr id="1" name=""/>
+        <p:cNvGrpSpPr/>
+        <p:nvPr/>
+      </p:nvGrpSpPr>
+      <p:grpSpPr>
+        <a:xfrm>
+          <a:off x="0" y="0"/>
+          <a:ext cx="0" cy="0"/>
+          <a:chOff x="0" y="0"/>
+          <a:chExt cx="0" cy="0"/>
+        </a:xfrm>
+      </p:grpSpPr>
+      <p:sp>
+        <p:nvSpPr>
           <p:cNvPr id="4" name="Titre 3">
             <a:extLst>
               <a:ext uri="{FF2B5EF4-FFF2-40B4-BE49-F238E27FC236}">
@@ -6462,7 +7487,7 @@
 </p:sld>
 </file>
 
-<file path=ppt/slides/slide3.xml><?xml version="1.0" encoding="utf-8"?>
+<file path=ppt/slides/slide4.xml><?xml version="1.0" encoding="utf-8"?>
 <p:sld xmlns:a="http://schemas.openxmlformats.org/drawingml/2006/main" xmlns:r="http://schemas.openxmlformats.org/officeDocument/2006/relationships" xmlns:p="http://schemas.openxmlformats.org/presentationml/2006/main">
   <p:cSld>
     <p:spTree>
@@ -6932,7 +7957,7 @@
 </p:sld>
 </file>
 
-<file path=ppt/slides/slide4.xml><?xml version="1.0" encoding="utf-8"?>
+<file path=ppt/slides/slide5.xml><?xml version="1.0" encoding="utf-8"?>
 <p:sld xmlns:a="http://schemas.openxmlformats.org/drawingml/2006/main" xmlns:r="http://schemas.openxmlformats.org/officeDocument/2006/relationships" xmlns:p="http://schemas.openxmlformats.org/presentationml/2006/main">
   <p:cSld>
     <p:spTree>
@@ -7256,7 +8281,7 @@
 </p:sld>
 </file>
 
-<file path=ppt/slides/slide5.xml><?xml version="1.0" encoding="utf-8"?>
+<file path=ppt/slides/slide6.xml><?xml version="1.0" encoding="utf-8"?>
 <p:sld xmlns:a="http://schemas.openxmlformats.org/drawingml/2006/main" xmlns:r="http://schemas.openxmlformats.org/officeDocument/2006/relationships" xmlns:p="http://schemas.openxmlformats.org/presentationml/2006/main">
   <p:cSld>
     <p:spTree>
@@ -8009,7 +9034,7 @@
 </p:sld>
 </file>
 
-<file path=ppt/slides/slide6.xml><?xml version="1.0" encoding="utf-8"?>
+<file path=ppt/slides/slide7.xml><?xml version="1.0" encoding="utf-8"?>
 <p:sld xmlns:a="http://schemas.openxmlformats.org/drawingml/2006/main" xmlns:r="http://schemas.openxmlformats.org/officeDocument/2006/relationships" xmlns:p="http://schemas.openxmlformats.org/presentationml/2006/main">
   <p:cSld>
     <p:spTree>
@@ -8598,7 +9623,7 @@
 </p:sld>
 </file>
 
-<file path=ppt/slides/slide7.xml><?xml version="1.0" encoding="utf-8"?>
+<file path=ppt/slides/slide8.xml><?xml version="1.0" encoding="utf-8"?>
 <p:sld xmlns:a="http://schemas.openxmlformats.org/drawingml/2006/main" xmlns:r="http://schemas.openxmlformats.org/officeDocument/2006/relationships" xmlns:p="http://schemas.openxmlformats.org/presentationml/2006/main">
   <p:cSld>
     <p:spTree>

</xml_diff>

<commit_message>
Domain management: Z order and automatic assignment + fixes in Archimate tool
</commit_message>
<xml_diff>
--- a/Specs/Mockup.pptx
+++ b/Specs/Mockup.pptx
@@ -13,6 +13,7 @@
     <p:sldId id="260" r:id="rId7"/>
     <p:sldId id="261" r:id="rId8"/>
     <p:sldId id="262" r:id="rId9"/>
+    <p:sldId id="264" r:id="rId10"/>
   </p:sldIdLst>
   <p:sldSz cx="12192000" cy="6858000"/>
   <p:notesSz cx="6858000" cy="9144000"/>
@@ -268,7 +269,7 @@
           <a:p>
             <a:fld id="{D38C393F-B997-4CF7-AD25-2687C8CBC838}" type="datetimeFigureOut">
               <a:rPr lang="en-US" smtClean="0"/>
-              <a:t>1/15/2026</a:t>
+              <a:t>1/21/2026</a:t>
             </a:fld>
             <a:endParaRPr lang="en-US"/>
           </a:p>
@@ -468,7 +469,7 @@
           <a:p>
             <a:fld id="{D38C393F-B997-4CF7-AD25-2687C8CBC838}" type="datetimeFigureOut">
               <a:rPr lang="en-US" smtClean="0"/>
-              <a:t>1/15/2026</a:t>
+              <a:t>1/21/2026</a:t>
             </a:fld>
             <a:endParaRPr lang="en-US"/>
           </a:p>
@@ -678,7 +679,7 @@
           <a:p>
             <a:fld id="{D38C393F-B997-4CF7-AD25-2687C8CBC838}" type="datetimeFigureOut">
               <a:rPr lang="en-US" smtClean="0"/>
-              <a:t>1/15/2026</a:t>
+              <a:t>1/21/2026</a:t>
             </a:fld>
             <a:endParaRPr lang="en-US"/>
           </a:p>
@@ -878,7 +879,7 @@
           <a:p>
             <a:fld id="{D38C393F-B997-4CF7-AD25-2687C8CBC838}" type="datetimeFigureOut">
               <a:rPr lang="en-US" smtClean="0"/>
-              <a:t>1/15/2026</a:t>
+              <a:t>1/21/2026</a:t>
             </a:fld>
             <a:endParaRPr lang="en-US"/>
           </a:p>
@@ -1154,7 +1155,7 @@
           <a:p>
             <a:fld id="{D38C393F-B997-4CF7-AD25-2687C8CBC838}" type="datetimeFigureOut">
               <a:rPr lang="en-US" smtClean="0"/>
-              <a:t>1/15/2026</a:t>
+              <a:t>1/21/2026</a:t>
             </a:fld>
             <a:endParaRPr lang="en-US"/>
           </a:p>
@@ -1422,7 +1423,7 @@
           <a:p>
             <a:fld id="{D38C393F-B997-4CF7-AD25-2687C8CBC838}" type="datetimeFigureOut">
               <a:rPr lang="en-US" smtClean="0"/>
-              <a:t>1/15/2026</a:t>
+              <a:t>1/21/2026</a:t>
             </a:fld>
             <a:endParaRPr lang="en-US"/>
           </a:p>
@@ -1837,7 +1838,7 @@
           <a:p>
             <a:fld id="{D38C393F-B997-4CF7-AD25-2687C8CBC838}" type="datetimeFigureOut">
               <a:rPr lang="en-US" smtClean="0"/>
-              <a:t>1/15/2026</a:t>
+              <a:t>1/21/2026</a:t>
             </a:fld>
             <a:endParaRPr lang="en-US"/>
           </a:p>
@@ -1979,7 +1980,7 @@
           <a:p>
             <a:fld id="{D38C393F-B997-4CF7-AD25-2687C8CBC838}" type="datetimeFigureOut">
               <a:rPr lang="en-US" smtClean="0"/>
-              <a:t>1/15/2026</a:t>
+              <a:t>1/21/2026</a:t>
             </a:fld>
             <a:endParaRPr lang="en-US"/>
           </a:p>
@@ -2092,7 +2093,7 @@
           <a:p>
             <a:fld id="{D38C393F-B997-4CF7-AD25-2687C8CBC838}" type="datetimeFigureOut">
               <a:rPr lang="en-US" smtClean="0"/>
-              <a:t>1/15/2026</a:t>
+              <a:t>1/21/2026</a:t>
             </a:fld>
             <a:endParaRPr lang="en-US"/>
           </a:p>
@@ -2405,7 +2406,7 @@
           <a:p>
             <a:fld id="{D38C393F-B997-4CF7-AD25-2687C8CBC838}" type="datetimeFigureOut">
               <a:rPr lang="en-US" smtClean="0"/>
-              <a:t>1/15/2026</a:t>
+              <a:t>1/21/2026</a:t>
             </a:fld>
             <a:endParaRPr lang="en-US"/>
           </a:p>
@@ -2694,7 +2695,7 @@
           <a:p>
             <a:fld id="{D38C393F-B997-4CF7-AD25-2687C8CBC838}" type="datetimeFigureOut">
               <a:rPr lang="en-US" smtClean="0"/>
-              <a:t>1/15/2026</a:t>
+              <a:t>1/21/2026</a:t>
             </a:fld>
             <a:endParaRPr lang="en-US"/>
           </a:p>
@@ -2937,7 +2938,7 @@
           <a:p>
             <a:fld id="{D38C393F-B997-4CF7-AD25-2687C8CBC838}" type="datetimeFigureOut">
               <a:rPr lang="en-US" smtClean="0"/>
-              <a:t>1/15/2026</a:t>
+              <a:t>1/21/2026</a:t>
             </a:fld>
             <a:endParaRPr lang="en-US"/>
           </a:p>
@@ -10133,6 +10134,281 @@
     <p:extLst>
       <p:ext uri="{BB962C8B-B14F-4D97-AF65-F5344CB8AC3E}">
         <p14:creationId xmlns:p14="http://schemas.microsoft.com/office/powerpoint/2010/main" val="2920823717"/>
+      </p:ext>
+    </p:extLst>
+  </p:cSld>
+  <p:clrMapOvr>
+    <a:masterClrMapping/>
+  </p:clrMapOvr>
+</p:sld>
+</file>
+
+<file path=ppt/slides/slide9.xml><?xml version="1.0" encoding="utf-8"?>
+<p:sld xmlns:a="http://schemas.openxmlformats.org/drawingml/2006/main" xmlns:r="http://schemas.openxmlformats.org/officeDocument/2006/relationships" xmlns:p="http://schemas.openxmlformats.org/presentationml/2006/main">
+  <p:cSld>
+    <p:spTree>
+      <p:nvGrpSpPr>
+        <p:cNvPr id="1" name=""/>
+        <p:cNvGrpSpPr/>
+        <p:nvPr/>
+      </p:nvGrpSpPr>
+      <p:grpSpPr>
+        <a:xfrm>
+          <a:off x="0" y="0"/>
+          <a:ext cx="0" cy="0"/>
+          <a:chOff x="0" y="0"/>
+          <a:chExt cx="0" cy="0"/>
+        </a:xfrm>
+      </p:grpSpPr>
+      <p:sp>
+        <p:nvSpPr>
+          <p:cNvPr id="2" name="Titre 1">
+            <a:extLst>
+              <a:ext uri="{FF2B5EF4-FFF2-40B4-BE49-F238E27FC236}">
+                <a16:creationId xmlns:a16="http://schemas.microsoft.com/office/drawing/2014/main" id="{2814E430-E7B2-6682-BC6D-E40BFC4090D1}"/>
+              </a:ext>
+            </a:extLst>
+          </p:cNvPr>
+          <p:cNvSpPr>
+            <a:spLocks noGrp="1"/>
+          </p:cNvSpPr>
+          <p:nvPr>
+            <p:ph type="title"/>
+          </p:nvPr>
+        </p:nvSpPr>
+        <p:spPr/>
+        <p:txBody>
+          <a:bodyPr/>
+          <a:lstStyle/>
+          <a:p>
+            <a:endParaRPr lang="en-US"/>
+          </a:p>
+        </p:txBody>
+      </p:sp>
+      <p:pic>
+        <p:nvPicPr>
+          <p:cNvPr id="4" name="Image 3">
+            <a:extLst>
+              <a:ext uri="{FF2B5EF4-FFF2-40B4-BE49-F238E27FC236}">
+                <a16:creationId xmlns:a16="http://schemas.microsoft.com/office/drawing/2014/main" id="{C319FE67-22E6-1CD4-DB11-2E665610AB7A}"/>
+              </a:ext>
+            </a:extLst>
+          </p:cNvPr>
+          <p:cNvPicPr>
+            <a:picLocks noChangeAspect="1"/>
+          </p:cNvPicPr>
+          <p:nvPr/>
+        </p:nvPicPr>
+        <p:blipFill>
+          <a:blip r:embed="rId2"/>
+          <a:stretch>
+            <a:fillRect/>
+          </a:stretch>
+        </p:blipFill>
+        <p:spPr>
+          <a:xfrm>
+            <a:off x="3859336" y="1344749"/>
+            <a:ext cx="4473328" cy="4168501"/>
+          </a:xfrm>
+          <a:prstGeom prst="rect">
+            <a:avLst/>
+          </a:prstGeom>
+        </p:spPr>
+      </p:pic>
+      <p:sp>
+        <p:nvSpPr>
+          <p:cNvPr id="5" name="Légende : encadrée 4">
+            <a:extLst>
+              <a:ext uri="{FF2B5EF4-FFF2-40B4-BE49-F238E27FC236}">
+                <a16:creationId xmlns:a16="http://schemas.microsoft.com/office/drawing/2014/main" id="{590D192E-1D56-0388-E34C-A6E90FDDDA67}"/>
+              </a:ext>
+            </a:extLst>
+          </p:cNvPr>
+          <p:cNvSpPr/>
+          <p:nvPr/>
+        </p:nvSpPr>
+        <p:spPr>
+          <a:xfrm>
+            <a:off x="9903941" y="3429000"/>
+            <a:ext cx="1927654" cy="1563130"/>
+          </a:xfrm>
+          <a:prstGeom prst="borderCallout1">
+            <a:avLst>
+              <a:gd name="adj1" fmla="val 18750"/>
+              <a:gd name="adj2" fmla="val -8333"/>
+              <a:gd name="adj3" fmla="val 63998"/>
+              <a:gd name="adj4" fmla="val -100253"/>
+            </a:avLst>
+          </a:prstGeom>
+        </p:spPr>
+        <p:style>
+          <a:lnRef idx="2">
+            <a:schemeClr val="accent1">
+              <a:shade val="15000"/>
+            </a:schemeClr>
+          </a:lnRef>
+          <a:fillRef idx="1">
+            <a:schemeClr val="accent1"/>
+          </a:fillRef>
+          <a:effectRef idx="0">
+            <a:schemeClr val="accent1"/>
+          </a:effectRef>
+          <a:fontRef idx="minor">
+            <a:schemeClr val="lt1"/>
+          </a:fontRef>
+        </p:style>
+        <p:txBody>
+          <a:bodyPr rtlCol="0" anchor="ctr"/>
+          <a:lstStyle/>
+          <a:p>
+            <a:pPr algn="ctr"/>
+            <a:r>
+              <a:rPr lang="fr-FR" dirty="0" err="1"/>
+              <a:t>We</a:t>
+            </a:r>
+            <a:r>
+              <a:rPr lang="fr-FR" dirty="0"/>
+              <a:t> </a:t>
+            </a:r>
+            <a:r>
+              <a:rPr lang="fr-FR" dirty="0" err="1"/>
+              <a:t>need</a:t>
+            </a:r>
+            <a:r>
+              <a:rPr lang="fr-FR" dirty="0"/>
+              <a:t> a </a:t>
+            </a:r>
+            <a:r>
+              <a:rPr lang="fr-FR" dirty="0" err="1"/>
+              <a:t>button</a:t>
+            </a:r>
+            <a:r>
+              <a:rPr lang="fr-FR" dirty="0"/>
+              <a:t> to </a:t>
+            </a:r>
+            <a:r>
+              <a:rPr lang="fr-FR" dirty="0" err="1"/>
+              <a:t>validate</a:t>
+            </a:r>
+            <a:r>
+              <a:rPr lang="fr-FR" dirty="0"/>
+              <a:t> the </a:t>
+            </a:r>
+            <a:r>
+              <a:rPr lang="fr-FR" dirty="0" err="1"/>
+              <a:t>selection</a:t>
+            </a:r>
+            <a:r>
+              <a:rPr lang="fr-FR" dirty="0"/>
+              <a:t> on </a:t>
+            </a:r>
+            <a:r>
+              <a:rPr lang="fr-FR" dirty="0" err="1"/>
+              <a:t>this</a:t>
+            </a:r>
+            <a:r>
+              <a:rPr lang="fr-FR" dirty="0"/>
+              <a:t> </a:t>
+            </a:r>
+            <a:r>
+              <a:rPr lang="fr-FR" dirty="0" err="1"/>
+              <a:t>this</a:t>
+            </a:r>
+            <a:r>
+              <a:rPr lang="fr-FR" dirty="0"/>
+              <a:t> popup</a:t>
+            </a:r>
+            <a:endParaRPr lang="en-US" dirty="0"/>
+          </a:p>
+        </p:txBody>
+      </p:sp>
+      <p:sp>
+        <p:nvSpPr>
+          <p:cNvPr id="6" name="Légende : encadrée 5">
+            <a:extLst>
+              <a:ext uri="{FF2B5EF4-FFF2-40B4-BE49-F238E27FC236}">
+                <a16:creationId xmlns:a16="http://schemas.microsoft.com/office/drawing/2014/main" id="{9AC95EA4-D651-EB66-5FF4-405CC55A22B7}"/>
+              </a:ext>
+            </a:extLst>
+          </p:cNvPr>
+          <p:cNvSpPr/>
+          <p:nvPr/>
+        </p:nvSpPr>
+        <p:spPr>
+          <a:xfrm>
+            <a:off x="9903940" y="2100649"/>
+            <a:ext cx="1927653" cy="1100740"/>
+          </a:xfrm>
+          <a:prstGeom prst="borderCallout1">
+            <a:avLst>
+              <a:gd name="adj1" fmla="val 18750"/>
+              <a:gd name="adj2" fmla="val -8333"/>
+              <a:gd name="adj3" fmla="val 90181"/>
+              <a:gd name="adj4" fmla="val -95973"/>
+            </a:avLst>
+          </a:prstGeom>
+        </p:spPr>
+        <p:style>
+          <a:lnRef idx="2">
+            <a:schemeClr val="accent1">
+              <a:shade val="15000"/>
+            </a:schemeClr>
+          </a:lnRef>
+          <a:fillRef idx="1">
+            <a:schemeClr val="accent1"/>
+          </a:fillRef>
+          <a:effectRef idx="0">
+            <a:schemeClr val="accent1"/>
+          </a:effectRef>
+          <a:fontRef idx="minor">
+            <a:schemeClr val="lt1"/>
+          </a:fontRef>
+        </p:style>
+        <p:txBody>
+          <a:bodyPr rtlCol="0" anchor="ctr"/>
+          <a:lstStyle/>
+          <a:p>
+            <a:pPr algn="ctr"/>
+            <a:r>
+              <a:rPr lang="fr-FR" dirty="0"/>
+              <a:t>The « </a:t>
+            </a:r>
+            <a:r>
+              <a:rPr lang="fr-FR" dirty="0" err="1"/>
+              <a:t>Done</a:t>
+            </a:r>
+            <a:r>
+              <a:rPr lang="fr-FR" dirty="0"/>
+              <a:t> » Button </a:t>
+            </a:r>
+            <a:r>
+              <a:rPr lang="fr-FR" dirty="0" err="1"/>
+              <a:t>was</a:t>
+            </a:r>
+            <a:r>
+              <a:rPr lang="fr-FR" dirty="0"/>
+              <a:t> fine. </a:t>
+            </a:r>
+            <a:r>
+              <a:rPr lang="fr-FR" dirty="0" err="1"/>
+              <a:t>Keep</a:t>
+            </a:r>
+            <a:r>
+              <a:rPr lang="fr-FR" dirty="0"/>
+              <a:t> </a:t>
+            </a:r>
+            <a:r>
+              <a:rPr lang="fr-FR" dirty="0" err="1"/>
+              <a:t>it</a:t>
+            </a:r>
+            <a:endParaRPr lang="en-US" dirty="0"/>
+          </a:p>
+        </p:txBody>
+      </p:sp>
+    </p:spTree>
+    <p:extLst>
+      <p:ext uri="{BB962C8B-B14F-4D97-AF65-F5344CB8AC3E}">
+        <p14:creationId xmlns:p14="http://schemas.microsoft.com/office/powerpoint/2010/main" val="3274605150"/>
       </p:ext>
     </p:extLst>
   </p:cSld>

</xml_diff>